<commit_message>
Minor changes to improve clarity in presentation 2
</commit_message>
<xml_diff>
--- a/files/web.pptx
+++ b/files/web.pptx
@@ -703,7 +703,7 @@
           <a:p>
             <a:fld id="{C6513600-717B-4CBB-9AFE-1F576C1D3E1D}" type="datetimeFigureOut">
               <a:rPr lang="he-IL" smtClean="0"/>
-              <a:t>כ"ב/חשון/תשפ"ו</a:t>
+              <a:t>כ"ה/חשון/תשפ"ו</a:t>
             </a:fld>
             <a:endParaRPr lang="he-IL"/>
           </a:p>
@@ -2466,7 +2466,7 @@
           <a:p>
             <a:fld id="{02109FA5-8937-4EFE-A1A6-BD6EB76E3D9A}" type="datetimeFigureOut">
               <a:rPr lang="he-IL" smtClean="0"/>
-              <a:t>כ"ב/חשון/תשפ"ו</a:t>
+              <a:t>כ"ה/חשון/תשפ"ו</a:t>
             </a:fld>
             <a:endParaRPr lang="he-IL"/>
           </a:p>
@@ -2666,7 +2666,7 @@
           <a:p>
             <a:fld id="{02109FA5-8937-4EFE-A1A6-BD6EB76E3D9A}" type="datetimeFigureOut">
               <a:rPr lang="he-IL" smtClean="0"/>
-              <a:t>כ"ב/חשון/תשפ"ו</a:t>
+              <a:t>כ"ה/חשון/תשפ"ו</a:t>
             </a:fld>
             <a:endParaRPr lang="he-IL"/>
           </a:p>
@@ -2876,7 +2876,7 @@
           <a:p>
             <a:fld id="{02109FA5-8937-4EFE-A1A6-BD6EB76E3D9A}" type="datetimeFigureOut">
               <a:rPr lang="he-IL" smtClean="0"/>
-              <a:t>כ"ב/חשון/תשפ"ו</a:t>
+              <a:t>כ"ה/חשון/תשפ"ו</a:t>
             </a:fld>
             <a:endParaRPr lang="he-IL"/>
           </a:p>
@@ -3076,7 +3076,7 @@
           <a:p>
             <a:fld id="{02109FA5-8937-4EFE-A1A6-BD6EB76E3D9A}" type="datetimeFigureOut">
               <a:rPr lang="he-IL" smtClean="0"/>
-              <a:t>כ"ב/חשון/תשפ"ו</a:t>
+              <a:t>כ"ה/חשון/תשפ"ו</a:t>
             </a:fld>
             <a:endParaRPr lang="he-IL"/>
           </a:p>
@@ -3352,7 +3352,7 @@
           <a:p>
             <a:fld id="{02109FA5-8937-4EFE-A1A6-BD6EB76E3D9A}" type="datetimeFigureOut">
               <a:rPr lang="he-IL" smtClean="0"/>
-              <a:t>כ"ב/חשון/תשפ"ו</a:t>
+              <a:t>כ"ה/חשון/תשפ"ו</a:t>
             </a:fld>
             <a:endParaRPr lang="he-IL"/>
           </a:p>
@@ -3620,7 +3620,7 @@
           <a:p>
             <a:fld id="{02109FA5-8937-4EFE-A1A6-BD6EB76E3D9A}" type="datetimeFigureOut">
               <a:rPr lang="he-IL" smtClean="0"/>
-              <a:t>כ"ב/חשון/תשפ"ו</a:t>
+              <a:t>כ"ה/חשון/תשפ"ו</a:t>
             </a:fld>
             <a:endParaRPr lang="he-IL"/>
           </a:p>
@@ -4035,7 +4035,7 @@
           <a:p>
             <a:fld id="{02109FA5-8937-4EFE-A1A6-BD6EB76E3D9A}" type="datetimeFigureOut">
               <a:rPr lang="he-IL" smtClean="0"/>
-              <a:t>כ"ב/חשון/תשפ"ו</a:t>
+              <a:t>כ"ה/חשון/תשפ"ו</a:t>
             </a:fld>
             <a:endParaRPr lang="he-IL"/>
           </a:p>
@@ -4177,7 +4177,7 @@
           <a:p>
             <a:fld id="{02109FA5-8937-4EFE-A1A6-BD6EB76E3D9A}" type="datetimeFigureOut">
               <a:rPr lang="he-IL" smtClean="0"/>
-              <a:t>כ"ב/חשון/תשפ"ו</a:t>
+              <a:t>כ"ה/חשון/תשפ"ו</a:t>
             </a:fld>
             <a:endParaRPr lang="he-IL"/>
           </a:p>
@@ -4290,7 +4290,7 @@
           <a:p>
             <a:fld id="{02109FA5-8937-4EFE-A1A6-BD6EB76E3D9A}" type="datetimeFigureOut">
               <a:rPr lang="he-IL" smtClean="0"/>
-              <a:t>כ"ב/חשון/תשפ"ו</a:t>
+              <a:t>כ"ה/חשון/תשפ"ו</a:t>
             </a:fld>
             <a:endParaRPr lang="he-IL"/>
           </a:p>
@@ -4603,7 +4603,7 @@
           <a:p>
             <a:fld id="{02109FA5-8937-4EFE-A1A6-BD6EB76E3D9A}" type="datetimeFigureOut">
               <a:rPr lang="he-IL" smtClean="0"/>
-              <a:t>כ"ב/חשון/תשפ"ו</a:t>
+              <a:t>כ"ה/חשון/תשפ"ו</a:t>
             </a:fld>
             <a:endParaRPr lang="he-IL"/>
           </a:p>
@@ -4896,7 +4896,7 @@
           <a:p>
             <a:fld id="{02109FA5-8937-4EFE-A1A6-BD6EB76E3D9A}" type="datetimeFigureOut">
               <a:rPr lang="he-IL" smtClean="0"/>
-              <a:t>כ"ב/חשון/תשפ"ו</a:t>
+              <a:t>כ"ה/חשון/תשפ"ו</a:t>
             </a:fld>
             <a:endParaRPr lang="he-IL"/>
           </a:p>
@@ -5139,7 +5139,7 @@
           <a:p>
             <a:fld id="{02109FA5-8937-4EFE-A1A6-BD6EB76E3D9A}" type="datetimeFigureOut">
               <a:rPr lang="he-IL" smtClean="0"/>
-              <a:t>כ"ב/חשון/תשפ"ו</a:t>
+              <a:t>כ"ה/חשון/תשפ"ו</a:t>
             </a:fld>
             <a:endParaRPr lang="he-IL"/>
           </a:p>
@@ -6725,7 +6725,7 @@
               <a:buChar char="•"/>
             </a:pPr>
             <a:r>
-              <a:rPr lang="en-US" sz="2800">
+              <a:rPr lang="en-US" sz="2800" dirty="0">
                 <a:solidFill>
                   <a:schemeClr val="bg1"/>
                 </a:solidFill>
@@ -6737,7 +6737,7 @@
           </a:p>
           <a:p>
             <a:r>
-              <a:rPr lang="en-US" sz="2800">
+              <a:rPr lang="en-US" sz="2800" dirty="0">
                 <a:solidFill>
                   <a:schemeClr val="bg1"/>
                 </a:solidFill>
@@ -6747,7 +6747,7 @@
               <a:t>   </a:t>
             </a:r>
             <a:r>
-              <a:rPr lang="en-US" sz="2800">
+              <a:rPr lang="en-US" sz="2800" dirty="0">
                 <a:solidFill>
                   <a:schemeClr val="bg1"/>
                 </a:solidFill>
@@ -6759,7 +6759,7 @@
           </a:p>
           <a:p>
             <a:r>
-              <a:rPr lang="en-US" sz="2800">
+              <a:rPr lang="en-US" sz="2800" dirty="0">
                 <a:solidFill>
                   <a:schemeClr val="bg1"/>
                 </a:solidFill>
@@ -6774,7 +6774,7 @@
               <a:buFont typeface="Arial"/>
               <a:buChar char="•"/>
             </a:pPr>
-            <a:endParaRPr lang="en-US" sz="2800">
+            <a:endParaRPr lang="en-US" sz="2800" dirty="0">
               <a:solidFill>
                 <a:schemeClr val="bg1"/>
               </a:solidFill>
@@ -6788,7 +6788,7 @@
               <a:buChar char="•"/>
             </a:pPr>
             <a:r>
-              <a:rPr lang="en-US" sz="2800">
+              <a:rPr lang="en-US" sz="2800" dirty="0">
                 <a:solidFill>
                   <a:schemeClr val="bg1"/>
                 </a:solidFill>
@@ -6797,7 +6797,7 @@
               </a:rPr>
               <a:t>If a user submits:</a:t>
             </a:r>
-            <a:endParaRPr lang="en-US" sz="2800">
+            <a:endParaRPr lang="en-US" sz="2800" dirty="0">
               <a:solidFill>
                 <a:schemeClr val="bg1"/>
               </a:solidFill>
@@ -6808,7 +6808,7 @@
           </a:p>
           <a:p>
             <a:r>
-              <a:rPr lang="en-US" sz="2800">
+              <a:rPr lang="en-US" sz="2800" dirty="0">
                 <a:solidFill>
                   <a:schemeClr val="bg1"/>
                 </a:solidFill>
@@ -6817,7 +6817,7 @@
               </a:rPr>
               <a:t>  username: ' OR 1=1 --</a:t>
             </a:r>
-            <a:endParaRPr lang="en-US" sz="2800">
+            <a:endParaRPr lang="en-US" sz="2800" dirty="0">
               <a:solidFill>
                 <a:schemeClr val="bg1"/>
               </a:solidFill>
@@ -6828,7 +6828,7 @@
           </a:p>
           <a:p>
             <a:r>
-              <a:rPr lang="en-US" sz="2800">
+              <a:rPr lang="en-US" sz="2800" dirty="0">
                 <a:solidFill>
                   <a:schemeClr val="bg1"/>
                 </a:solidFill>
@@ -6837,7 +6837,7 @@
               </a:rPr>
               <a:t>  password: Anything</a:t>
             </a:r>
-            <a:endParaRPr lang="en-US" sz="2800">
+            <a:endParaRPr lang="en-US" sz="2800" dirty="0">
               <a:solidFill>
                 <a:schemeClr val="bg1"/>
               </a:solidFill>
@@ -6846,7 +6846,7 @@
             </a:endParaRPr>
           </a:p>
           <a:p>
-            <a:endParaRPr lang="en-US" sz="2800">
+            <a:endParaRPr lang="en-US" sz="2800" dirty="0">
               <a:solidFill>
                 <a:schemeClr val="bg1"/>
               </a:solidFill>
@@ -6860,7 +6860,7 @@
               <a:buChar char="•"/>
             </a:pPr>
             <a:r>
-              <a:rPr lang="en-US" sz="2800">
+              <a:rPr lang="en-US" sz="2800" dirty="0">
                 <a:solidFill>
                   <a:schemeClr val="bg1"/>
                 </a:solidFill>
@@ -6872,7 +6872,7 @@
           </a:p>
           <a:p>
             <a:r>
-              <a:rPr lang="en-US" sz="2800">
+              <a:rPr lang="en-US" sz="2800" dirty="0">
                 <a:solidFill>
                   <a:schemeClr val="bg1"/>
                 </a:solidFill>
@@ -6884,17 +6884,27 @@
           </a:p>
           <a:p>
             <a:r>
-              <a:rPr lang="en-US" sz="2800">
+              <a:rPr lang="en-US" sz="2800" dirty="0">
                 <a:solidFill>
                   <a:schemeClr val="bg1"/>
                 </a:solidFill>
                 <a:latin typeface="Aptos"/>
                 <a:cs typeface="Miriam Libre"/>
               </a:rPr>
-              <a:t>   WHERE username = '' OR 1=1 -- </a:t>
-            </a:r>
-            <a:r>
-              <a:rPr lang="en-US" sz="2800" i="1">
+              <a:t>   WHERE username = '</a:t>
+            </a:r>
+            <a:r>
+              <a:rPr lang="en-US" sz="2800" dirty="0">
+                <a:solidFill>
+                  <a:schemeClr val="accent2"/>
+                </a:solidFill>
+                <a:latin typeface="Aptos"/>
+                <a:cs typeface="Miriam Libre"/>
+              </a:rPr>
+              <a:t>' OR 1=1 -- </a:t>
+            </a:r>
+            <a:r>
+              <a:rPr lang="en-US" sz="2800" i="1" dirty="0">
                 <a:solidFill>
                   <a:schemeClr val="bg1">
                     <a:lumMod val="65000"/>
@@ -6911,7 +6921,7 @@
               <a:buFont typeface="Arial" panose="020B0604020202020204" pitchFamily="34" charset="0"/>
               <a:buChar char="•"/>
             </a:pPr>
-            <a:endParaRPr lang="en-US" sz="2800">
+            <a:endParaRPr lang="en-US" sz="2800" dirty="0">
               <a:solidFill>
                 <a:schemeClr val="bg1"/>
               </a:solidFill>
@@ -7242,7 +7252,7 @@
               <a:buChar char="•"/>
             </a:pPr>
             <a:r>
-              <a:rPr lang="en-US" sz="2800">
+              <a:rPr lang="en-US" sz="2800" dirty="0">
                 <a:solidFill>
                   <a:schemeClr val="bg1"/>
                 </a:solidFill>
@@ -7254,7 +7264,7 @@
           </a:p>
           <a:p>
             <a:r>
-              <a:rPr lang="en-US" sz="2800">
+              <a:rPr lang="en-US" sz="2800" dirty="0">
                 <a:solidFill>
                   <a:schemeClr val="bg1"/>
                 </a:solidFill>
@@ -7266,17 +7276,36 @@
           </a:p>
           <a:p>
             <a:r>
-              <a:rPr lang="en-US" sz="2800">
+              <a:rPr lang="en-US" sz="2800" dirty="0">
                 <a:solidFill>
                   <a:schemeClr val="bg1"/>
                 </a:solidFill>
                 <a:latin typeface="Aptos"/>
                 <a:cs typeface="Miriam Libre"/>
               </a:rPr>
-              <a:t>   WHERE username = '' OR 1=1 -- </a:t>
-            </a:r>
-            <a:r>
-              <a:rPr lang="en-US" sz="2800" i="1">
+              <a:t>   WHERE username = '</a:t>
+            </a:r>
+            <a:r>
+              <a:rPr lang="en-US" sz="2800" dirty="0">
+                <a:solidFill>
+                  <a:schemeClr val="accent2"/>
+                </a:solidFill>
+                <a:cs typeface="Miriam Libre"/>
+              </a:rPr>
+              <a:t>' OR 1=1 -- </a:t>
+            </a:r>
+            <a:r>
+              <a:rPr lang="en-US" sz="2800" dirty="0">
+                <a:solidFill>
+                  <a:schemeClr val="bg1"/>
+                </a:solidFill>
+                <a:latin typeface="Aptos"/>
+                <a:cs typeface="Miriam Libre"/>
+              </a:rPr>
+              <a:t> </a:t>
+            </a:r>
+            <a:r>
+              <a:rPr lang="en-US" sz="2800" i="1" dirty="0">
                 <a:solidFill>
                   <a:schemeClr val="bg1">
                     <a:lumMod val="65000"/>
@@ -7293,7 +7322,7 @@
               <a:buFont typeface="Arial" panose="020B0604020202020204" pitchFamily="34" charset="0"/>
               <a:buChar char="•"/>
             </a:pPr>
-            <a:endParaRPr lang="en-US" sz="2800">
+            <a:endParaRPr lang="en-US" sz="2800" dirty="0">
               <a:solidFill>
                 <a:schemeClr val="bg1"/>
               </a:solidFill>
@@ -7307,7 +7336,7 @@
               <a:buChar char="•"/>
             </a:pPr>
             <a:r>
-              <a:rPr lang="en-US" sz="2800">
+              <a:rPr lang="en-US" sz="2800" dirty="0">
                 <a:solidFill>
                   <a:schemeClr val="bg1"/>
                 </a:solidFill>
@@ -7322,7 +7351,7 @@
               <a:buFont typeface="Arial" panose="020B0604020202020204" pitchFamily="34" charset="0"/>
               <a:buChar char="•"/>
             </a:pPr>
-            <a:endParaRPr lang="en-US" sz="2800">
+            <a:endParaRPr lang="en-US" sz="2800" dirty="0">
               <a:solidFill>
                 <a:schemeClr val="bg1"/>
               </a:solidFill>
@@ -7336,7 +7365,7 @@
               <a:buChar char="•"/>
             </a:pPr>
             <a:r>
-              <a:rPr lang="en-US" sz="2800">
+              <a:rPr lang="en-US" sz="2800" dirty="0">
                 <a:solidFill>
                   <a:schemeClr val="bg1"/>
                 </a:solidFill>
@@ -8179,7 +8208,7 @@
               <a:buFont typeface="Arial"/>
               <a:buChar char="•"/>
             </a:pPr>
-            <a:endParaRPr lang="en-US" sz="2800">
+            <a:endParaRPr lang="en-US" sz="2800" dirty="0">
               <a:solidFill>
                 <a:schemeClr val="bg1"/>
               </a:solidFill>

</xml_diff>